<commit_message>
Add name and student ID to slides (anh-le)
Co-Authored-By: Claude Opus 5.5 <noreply@anthropic.com>
</commit_message>
<xml_diff>
--- a/anh-le/G03_slide.pptx
+++ b/anh-le/G03_slide.pptx
@@ -3674,6 +3674,21 @@
               <a:t>Track 2 · Production Capstone · Nhóm G03</a:t>
             </a:r>
           </a:p>
+          <a:p>
+            <a:pPr algn="l">
+              <a:spcAft>
+                <a:spcPts val="400"/>
+              </a:spcAft>
+            </a:pPr>
+            <a:r>
+              <a:rPr sz="1800" b="0">
+                <a:solidFill>
+                  <a:srgbClr val="BFD7EA"/>
+                </a:solidFill>
+              </a:rPr>
+              <a:t>Lê Tuấn Anh · MSSV 2A202602952</a:t>
+            </a:r>
+          </a:p>
         </p:txBody>
       </p:sp>
     </p:spTree>
@@ -3884,7 +3899,7 @@
                   <a:srgbClr val="555F6B"/>
                 </a:solidFill>
               </a:rPr>
-              <a:t>G03 · VBot Workplace · GCP asia-southeast1</a:t>
+              <a:t>G03 · VBot Workplace · Lê Tuấn Anh · MSSV 2A202602952</a:t>
             </a:r>
           </a:p>
         </p:txBody>
@@ -4471,7 +4486,7 @@
                   <a:srgbClr val="555F6B"/>
                 </a:solidFill>
               </a:rPr>
-              <a:t>G03 · VBot Workplace · GCP asia-southeast1</a:t>
+              <a:t>G03 · VBot Workplace · Lê Tuấn Anh · MSSV 2A202602952</a:t>
             </a:r>
           </a:p>
         </p:txBody>
@@ -4978,7 +4993,7 @@
                   <a:srgbClr val="555F6B"/>
                 </a:solidFill>
               </a:rPr>
-              <a:t>G03 · VBot Workplace · GCP asia-southeast1</a:t>
+              <a:t>G03 · VBot Workplace · Lê Tuấn Anh · MSSV 2A202602952</a:t>
             </a:r>
           </a:p>
         </p:txBody>
@@ -5881,7 +5896,7 @@
                   <a:srgbClr val="555F6B"/>
                 </a:solidFill>
               </a:rPr>
-              <a:t>G03 · VBot Workplace · GCP asia-southeast1</a:t>
+              <a:t>G03 · VBot Workplace · Lê Tuấn Anh · MSSV 2A202602952</a:t>
             </a:r>
           </a:p>
         </p:txBody>
@@ -6566,7 +6581,7 @@
                   <a:srgbClr val="555F6B"/>
                 </a:solidFill>
               </a:rPr>
-              <a:t>G03 · VBot Workplace · GCP asia-southeast1</a:t>
+              <a:t>G03 · VBot Workplace · Lê Tuấn Anh · MSSV 2A202602952</a:t>
             </a:r>
           </a:p>
         </p:txBody>
@@ -7595,7 +7610,7 @@
                   <a:srgbClr val="555F6B"/>
                 </a:solidFill>
               </a:rPr>
-              <a:t>G03 · VBot Workplace · GCP asia-southeast1</a:t>
+              <a:t>G03 · VBot Workplace · Lê Tuấn Anh · MSSV 2A202602952</a:t>
             </a:r>
           </a:p>
         </p:txBody>
@@ -8473,7 +8488,7 @@
                   <a:srgbClr val="555F6B"/>
                 </a:solidFill>
               </a:rPr>
-              <a:t>G03 · VBot Workplace · GCP asia-southeast1</a:t>
+              <a:t>G03 · VBot Workplace · Lê Tuấn Anh · MSSV 2A202602952</a:t>
             </a:r>
           </a:p>
         </p:txBody>
@@ -9364,7 +9379,7 @@
                   <a:srgbClr val="555F6B"/>
                 </a:solidFill>
               </a:rPr>
-              <a:t>G03 · VBot Workplace · GCP asia-southeast1</a:t>
+              <a:t>G03 · VBot Workplace · Lê Tuấn Anh · MSSV 2A202602952</a:t>
             </a:r>
           </a:p>
         </p:txBody>
@@ -10603,7 +10618,7 @@
                   <a:srgbClr val="555F6B"/>
                 </a:solidFill>
               </a:rPr>
-              <a:t>G03 · VBot Workplace · GCP asia-southeast1</a:t>
+              <a:t>G03 · VBot Workplace · Lê Tuấn Anh · MSSV 2A202602952</a:t>
             </a:r>
           </a:p>
         </p:txBody>
@@ -10974,7 +10989,7 @@
                   <a:srgbClr val="555F6B"/>
                 </a:solidFill>
               </a:rPr>
-              <a:t>G03 · VBot Workplace · GCP asia-southeast1</a:t>
+              <a:t>G03 · VBot Workplace · Lê Tuấn Anh · MSSV 2A202602952</a:t>
             </a:r>
           </a:p>
         </p:txBody>
@@ -12145,7 +12160,7 @@
                   <a:srgbClr val="555F6B"/>
                 </a:solidFill>
               </a:rPr>
-              <a:t>G03 · VBot Workplace · GCP asia-southeast1</a:t>
+              <a:t>G03 · VBot Workplace · Lê Tuấn Anh · MSSV 2A202602952</a:t>
             </a:r>
           </a:p>
         </p:txBody>
@@ -14252,7 +14267,7 @@
                   <a:srgbClr val="555F6B"/>
                 </a:solidFill>
               </a:rPr>
-              <a:t>G03 · VBot Workplace · GCP asia-southeast1</a:t>
+              <a:t>G03 · VBot Workplace · Lê Tuấn Anh · MSSV 2A202602952</a:t>
             </a:r>
           </a:p>
         </p:txBody>
@@ -15584,7 +15599,7 @@
                   <a:srgbClr val="555F6B"/>
                 </a:solidFill>
               </a:rPr>
-              <a:t>G03 · VBot Workplace · GCP asia-southeast1</a:t>
+              <a:t>G03 · VBot Workplace · Lê Tuấn Anh · MSSV 2A202602952</a:t>
             </a:r>
           </a:p>
         </p:txBody>
@@ -16397,7 +16412,7 @@
                   <a:srgbClr val="555F6B"/>
                 </a:solidFill>
               </a:rPr>
-              <a:t>G03 · VBot Workplace · GCP asia-southeast1</a:t>
+              <a:t>G03 · VBot Workplace · Lê Tuấn Anh · MSSV 2A202602952</a:t>
             </a:r>
           </a:p>
         </p:txBody>
@@ -18311,7 +18326,7 @@
                   <a:srgbClr val="555F6B"/>
                 </a:solidFill>
               </a:rPr>
-              <a:t>G03 · VBot Workplace · GCP asia-southeast1</a:t>
+              <a:t>G03 · VBot Workplace · Lê Tuấn Anh · MSSV 2A202602952</a:t>
             </a:r>
           </a:p>
         </p:txBody>
@@ -18727,7 +18742,7 @@
                   <a:srgbClr val="555F6B"/>
                 </a:solidFill>
               </a:rPr>
-              <a:t>G03 · VBot Workplace · GCP asia-southeast1</a:t>
+              <a:t>G03 · VBot Workplace · Lê Tuấn Anh · MSSV 2A202602952</a:t>
             </a:r>
           </a:p>
         </p:txBody>
@@ -20085,7 +20100,7 @@
                   <a:srgbClr val="555F6B"/>
                 </a:solidFill>
               </a:rPr>
-              <a:t>G03 · VBot Workplace · GCP asia-southeast1</a:t>
+              <a:t>G03 · VBot Workplace · Lê Tuấn Anh · MSSV 2A202602952</a:t>
             </a:r>
           </a:p>
         </p:txBody>
@@ -21052,7 +21067,7 @@
                   <a:srgbClr val="555F6B"/>
                 </a:solidFill>
               </a:rPr>
-              <a:t>G03 · VBot Workplace · GCP asia-southeast1</a:t>
+              <a:t>G03 · VBot Workplace · Lê Tuấn Anh · MSSV 2A202602952</a:t>
             </a:r>
           </a:p>
         </p:txBody>
@@ -21800,7 +21815,7 @@
                   <a:srgbClr val="555F6B"/>
                 </a:solidFill>
               </a:rPr>
-              <a:t>G03 · VBot Workplace · GCP asia-southeast1</a:t>
+              <a:t>G03 · VBot Workplace · Lê Tuấn Anh · MSSV 2A202602952</a:t>
             </a:r>
           </a:p>
         </p:txBody>

</xml_diff>

<commit_message>
List all 3 team members with student IDs on slides (anh-le)
Co-Authored-By: Claude Opus 5.5 <noreply@anthropic.com>
</commit_message>
<xml_diff>
--- a/anh-le/G03_slide.pptx
+++ b/anh-le/G03_slide.pptx
@@ -3555,7 +3555,7 @@
         </p:nvSpPr>
         <p:spPr>
           <a:xfrm>
-            <a:off x="731520" y="1828800"/>
+            <a:off x="731520" y="1280160"/>
             <a:ext cx="10515600" cy="1097280"/>
           </a:xfrm>
           <a:prstGeom prst="rect">
@@ -3593,7 +3593,7 @@
         </p:nvSpPr>
         <p:spPr>
           <a:xfrm>
-            <a:off x="731520" y="2834640"/>
+            <a:off x="731520" y="2286000"/>
             <a:ext cx="10515600" cy="731520"/>
           </a:xfrm>
           <a:prstGeom prst="rect">
@@ -3631,7 +3631,7 @@
         </p:nvSpPr>
         <p:spPr>
           <a:xfrm>
-            <a:off x="731520" y="3931920"/>
+            <a:off x="731520" y="3291840"/>
             <a:ext cx="10515600" cy="1097280"/>
           </a:xfrm>
           <a:prstGeom prst="rect">
@@ -3674,6 +3674,29 @@
               <a:t>Track 2 · Production Capstone · Nhóm G03</a:t>
             </a:r>
           </a:p>
+        </p:txBody>
+      </p:sp>
+      <p:sp>
+        <p:nvSpPr>
+          <p:cNvPr id="6" name="TextBox 5"/>
+          <p:cNvSpPr txBox="1"/>
+          <p:nvPr/>
+        </p:nvSpPr>
+        <p:spPr>
+          <a:xfrm>
+            <a:off x="731520" y="4389120"/>
+            <a:ext cx="10515600" cy="1645920"/>
+          </a:xfrm>
+          <a:prstGeom prst="rect">
+            <a:avLst/>
+          </a:prstGeom>
+          <a:noFill/>
+        </p:spPr>
+        <p:txBody>
+          <a:bodyPr wrap="square">
+            <a:spAutoFit/>
+          </a:bodyPr>
+          <a:lstStyle/>
           <a:p>
             <a:pPr algn="l">
               <a:spcAft>
@@ -3681,12 +3704,57 @@
               </a:spcAft>
             </a:pPr>
             <a:r>
-              <a:rPr sz="1800" b="0">
-                <a:solidFill>
-                  <a:srgbClr val="BFD7EA"/>
+              <a:rPr sz="1600" b="1">
+                <a:solidFill>
+                  <a:srgbClr val="FFFFFF"/>
+                </a:solidFill>
+              </a:rPr>
+              <a:t>Thành viên</a:t>
+            </a:r>
+          </a:p>
+          <a:p>
+            <a:pPr algn="l">
+              <a:spcAft>
+                <a:spcPts val="400"/>
+              </a:spcAft>
+            </a:pPr>
+            <a:r>
+              <a:rPr sz="1600" b="0">
+                <a:solidFill>
+                  <a:srgbClr val="FFFFFF"/>
                 </a:solidFill>
               </a:rPr>
               <a:t>Lê Tuấn Anh · MSSV 2A202602952</a:t>
+            </a:r>
+          </a:p>
+          <a:p>
+            <a:pPr algn="l">
+              <a:spcAft>
+                <a:spcPts val="400"/>
+              </a:spcAft>
+            </a:pPr>
+            <a:r>
+              <a:rPr sz="1600" b="0">
+                <a:solidFill>
+                  <a:srgbClr val="FFFFFF"/>
+                </a:solidFill>
+              </a:rPr>
+              <a:t>Hồ Thái Hòa · MSSV 2A202602915</a:t>
+            </a:r>
+          </a:p>
+          <a:p>
+            <a:pPr algn="l">
+              <a:spcAft>
+                <a:spcPts val="400"/>
+              </a:spcAft>
+            </a:pPr>
+            <a:r>
+              <a:rPr sz="1600" b="0">
+                <a:solidFill>
+                  <a:srgbClr val="FFFFFF"/>
+                </a:solidFill>
+              </a:rPr>
+              <a:t>Nguyễn Đình Lâm Phúc · MSSV 2A202602986</a:t>
             </a:r>
           </a:p>
         </p:txBody>
@@ -3875,7 +3943,7 @@
         <p:spPr>
           <a:xfrm>
             <a:off x="457200" y="6400800"/>
-            <a:ext cx="7315200" cy="365760"/>
+            <a:ext cx="9144000" cy="365760"/>
           </a:xfrm>
           <a:prstGeom prst="rect">
             <a:avLst/>
@@ -3899,7 +3967,7 @@
                   <a:srgbClr val="555F6B"/>
                 </a:solidFill>
               </a:rPr>
-              <a:t>G03 · VBot Workplace · Lê Tuấn Anh · MSSV 2A202602952</a:t>
+              <a:t>G03 · Lê Tuấn Anh (2A202602952) · Hồ Thái Hòa (2A202602915) · Nguyễn Đình Lâm Phúc (2A202602986)</a:t>
             </a:r>
           </a:p>
         </p:txBody>
@@ -4462,7 +4530,7 @@
         <p:spPr>
           <a:xfrm>
             <a:off x="457200" y="6400800"/>
-            <a:ext cx="7315200" cy="365760"/>
+            <a:ext cx="9144000" cy="365760"/>
           </a:xfrm>
           <a:prstGeom prst="rect">
             <a:avLst/>
@@ -4486,7 +4554,7 @@
                   <a:srgbClr val="555F6B"/>
                 </a:solidFill>
               </a:rPr>
-              <a:t>G03 · VBot Workplace · Lê Tuấn Anh · MSSV 2A202602952</a:t>
+              <a:t>G03 · Lê Tuấn Anh (2A202602952) · Hồ Thái Hòa (2A202602915) · Nguyễn Đình Lâm Phúc (2A202602986)</a:t>
             </a:r>
           </a:p>
         </p:txBody>
@@ -4969,7 +5037,7 @@
         <p:spPr>
           <a:xfrm>
             <a:off x="457200" y="6400800"/>
-            <a:ext cx="7315200" cy="365760"/>
+            <a:ext cx="9144000" cy="365760"/>
           </a:xfrm>
           <a:prstGeom prst="rect">
             <a:avLst/>
@@ -4993,7 +5061,7 @@
                   <a:srgbClr val="555F6B"/>
                 </a:solidFill>
               </a:rPr>
-              <a:t>G03 · VBot Workplace · Lê Tuấn Anh · MSSV 2A202602952</a:t>
+              <a:t>G03 · Lê Tuấn Anh (2A202602952) · Hồ Thái Hòa (2A202602915) · Nguyễn Đình Lâm Phúc (2A202602986)</a:t>
             </a:r>
           </a:p>
         </p:txBody>
@@ -5872,7 +5940,7 @@
         <p:spPr>
           <a:xfrm>
             <a:off x="457200" y="6400800"/>
-            <a:ext cx="7315200" cy="365760"/>
+            <a:ext cx="9144000" cy="365760"/>
           </a:xfrm>
           <a:prstGeom prst="rect">
             <a:avLst/>
@@ -5896,7 +5964,7 @@
                   <a:srgbClr val="555F6B"/>
                 </a:solidFill>
               </a:rPr>
-              <a:t>G03 · VBot Workplace · Lê Tuấn Anh · MSSV 2A202602952</a:t>
+              <a:t>G03 · Lê Tuấn Anh (2A202602952) · Hồ Thái Hòa (2A202602915) · Nguyễn Đình Lâm Phúc (2A202602986)</a:t>
             </a:r>
           </a:p>
         </p:txBody>
@@ -6557,7 +6625,7 @@
         <p:spPr>
           <a:xfrm>
             <a:off x="457200" y="6400800"/>
-            <a:ext cx="7315200" cy="365760"/>
+            <a:ext cx="9144000" cy="365760"/>
           </a:xfrm>
           <a:prstGeom prst="rect">
             <a:avLst/>
@@ -6581,7 +6649,7 @@
                   <a:srgbClr val="555F6B"/>
                 </a:solidFill>
               </a:rPr>
-              <a:t>G03 · VBot Workplace · Lê Tuấn Anh · MSSV 2A202602952</a:t>
+              <a:t>G03 · Lê Tuấn Anh (2A202602952) · Hồ Thái Hòa (2A202602915) · Nguyễn Đình Lâm Phúc (2A202602986)</a:t>
             </a:r>
           </a:p>
         </p:txBody>
@@ -7586,7 +7654,7 @@
         <p:spPr>
           <a:xfrm>
             <a:off x="457200" y="6400800"/>
-            <a:ext cx="7315200" cy="365760"/>
+            <a:ext cx="9144000" cy="365760"/>
           </a:xfrm>
           <a:prstGeom prst="rect">
             <a:avLst/>
@@ -7610,7 +7678,7 @@
                   <a:srgbClr val="555F6B"/>
                 </a:solidFill>
               </a:rPr>
-              <a:t>G03 · VBot Workplace · Lê Tuấn Anh · MSSV 2A202602952</a:t>
+              <a:t>G03 · Lê Tuấn Anh (2A202602952) · Hồ Thái Hòa (2A202602915) · Nguyễn Đình Lâm Phúc (2A202602986)</a:t>
             </a:r>
           </a:p>
         </p:txBody>
@@ -8464,7 +8532,7 @@
         <p:spPr>
           <a:xfrm>
             <a:off x="457200" y="6400800"/>
-            <a:ext cx="7315200" cy="365760"/>
+            <a:ext cx="9144000" cy="365760"/>
           </a:xfrm>
           <a:prstGeom prst="rect">
             <a:avLst/>
@@ -8488,7 +8556,7 @@
                   <a:srgbClr val="555F6B"/>
                 </a:solidFill>
               </a:rPr>
-              <a:t>G03 · VBot Workplace · Lê Tuấn Anh · MSSV 2A202602952</a:t>
+              <a:t>G03 · Lê Tuấn Anh (2A202602952) · Hồ Thái Hòa (2A202602915) · Nguyễn Đình Lâm Phúc (2A202602986)</a:t>
             </a:r>
           </a:p>
         </p:txBody>
@@ -9355,7 +9423,7 @@
         <p:spPr>
           <a:xfrm>
             <a:off x="457200" y="6400800"/>
-            <a:ext cx="7315200" cy="365760"/>
+            <a:ext cx="9144000" cy="365760"/>
           </a:xfrm>
           <a:prstGeom prst="rect">
             <a:avLst/>
@@ -9379,7 +9447,7 @@
                   <a:srgbClr val="555F6B"/>
                 </a:solidFill>
               </a:rPr>
-              <a:t>G03 · VBot Workplace · Lê Tuấn Anh · MSSV 2A202602952</a:t>
+              <a:t>G03 · Lê Tuấn Anh (2A202602952) · Hồ Thái Hòa (2A202602915) · Nguyễn Đình Lâm Phúc (2A202602986)</a:t>
             </a:r>
           </a:p>
         </p:txBody>
@@ -10594,7 +10662,7 @@
         <p:spPr>
           <a:xfrm>
             <a:off x="457200" y="6400800"/>
-            <a:ext cx="7315200" cy="365760"/>
+            <a:ext cx="9144000" cy="365760"/>
           </a:xfrm>
           <a:prstGeom prst="rect">
             <a:avLst/>
@@ -10618,7 +10686,7 @@
                   <a:srgbClr val="555F6B"/>
                 </a:solidFill>
               </a:rPr>
-              <a:t>G03 · VBot Workplace · Lê Tuấn Anh · MSSV 2A202602952</a:t>
+              <a:t>G03 · Lê Tuấn Anh (2A202602952) · Hồ Thái Hòa (2A202602915) · Nguyễn Đình Lâm Phúc (2A202602986)</a:t>
             </a:r>
           </a:p>
         </p:txBody>
@@ -10965,7 +11033,7 @@
         <p:spPr>
           <a:xfrm>
             <a:off x="457200" y="6400800"/>
-            <a:ext cx="7315200" cy="365760"/>
+            <a:ext cx="9144000" cy="365760"/>
           </a:xfrm>
           <a:prstGeom prst="rect">
             <a:avLst/>
@@ -10989,7 +11057,7 @@
                   <a:srgbClr val="555F6B"/>
                 </a:solidFill>
               </a:rPr>
-              <a:t>G03 · VBot Workplace · Lê Tuấn Anh · MSSV 2A202602952</a:t>
+              <a:t>G03 · Lê Tuấn Anh (2A202602952) · Hồ Thái Hòa (2A202602915) · Nguyễn Đình Lâm Phúc (2A202602986)</a:t>
             </a:r>
           </a:p>
         </p:txBody>
@@ -12136,7 +12204,7 @@
         <p:spPr>
           <a:xfrm>
             <a:off x="457200" y="6400800"/>
-            <a:ext cx="7315200" cy="365760"/>
+            <a:ext cx="9144000" cy="365760"/>
           </a:xfrm>
           <a:prstGeom prst="rect">
             <a:avLst/>
@@ -12160,7 +12228,7 @@
                   <a:srgbClr val="555F6B"/>
                 </a:solidFill>
               </a:rPr>
-              <a:t>G03 · VBot Workplace · Lê Tuấn Anh · MSSV 2A202602952</a:t>
+              <a:t>G03 · Lê Tuấn Anh (2A202602952) · Hồ Thái Hòa (2A202602915) · Nguyễn Đình Lâm Phúc (2A202602986)</a:t>
             </a:r>
           </a:p>
         </p:txBody>
@@ -14243,7 +14311,7 @@
         <p:spPr>
           <a:xfrm>
             <a:off x="457200" y="6400800"/>
-            <a:ext cx="7315200" cy="365760"/>
+            <a:ext cx="9144000" cy="365760"/>
           </a:xfrm>
           <a:prstGeom prst="rect">
             <a:avLst/>
@@ -14267,7 +14335,7 @@
                   <a:srgbClr val="555F6B"/>
                 </a:solidFill>
               </a:rPr>
-              <a:t>G03 · VBot Workplace · Lê Tuấn Anh · MSSV 2A202602952</a:t>
+              <a:t>G03 · Lê Tuấn Anh (2A202602952) · Hồ Thái Hòa (2A202602915) · Nguyễn Đình Lâm Phúc (2A202602986)</a:t>
             </a:r>
           </a:p>
         </p:txBody>
@@ -15575,7 +15643,7 @@
         <p:spPr>
           <a:xfrm>
             <a:off x="457200" y="6400800"/>
-            <a:ext cx="7315200" cy="365760"/>
+            <a:ext cx="9144000" cy="365760"/>
           </a:xfrm>
           <a:prstGeom prst="rect">
             <a:avLst/>
@@ -15599,7 +15667,7 @@
                   <a:srgbClr val="555F6B"/>
                 </a:solidFill>
               </a:rPr>
-              <a:t>G03 · VBot Workplace · Lê Tuấn Anh · MSSV 2A202602952</a:t>
+              <a:t>G03 · Lê Tuấn Anh (2A202602952) · Hồ Thái Hòa (2A202602915) · Nguyễn Đình Lâm Phúc (2A202602986)</a:t>
             </a:r>
           </a:p>
         </p:txBody>
@@ -16388,7 +16456,7 @@
         <p:spPr>
           <a:xfrm>
             <a:off x="457200" y="6400800"/>
-            <a:ext cx="7315200" cy="365760"/>
+            <a:ext cx="9144000" cy="365760"/>
           </a:xfrm>
           <a:prstGeom prst="rect">
             <a:avLst/>
@@ -16412,7 +16480,7 @@
                   <a:srgbClr val="555F6B"/>
                 </a:solidFill>
               </a:rPr>
-              <a:t>G03 · VBot Workplace · Lê Tuấn Anh · MSSV 2A202602952</a:t>
+              <a:t>G03 · Lê Tuấn Anh (2A202602952) · Hồ Thái Hòa (2A202602915) · Nguyễn Đình Lâm Phúc (2A202602986)</a:t>
             </a:r>
           </a:p>
         </p:txBody>
@@ -18302,7 +18370,7 @@
         <p:spPr>
           <a:xfrm>
             <a:off x="457200" y="6400800"/>
-            <a:ext cx="7315200" cy="365760"/>
+            <a:ext cx="9144000" cy="365760"/>
           </a:xfrm>
           <a:prstGeom prst="rect">
             <a:avLst/>
@@ -18326,7 +18394,7 @@
                   <a:srgbClr val="555F6B"/>
                 </a:solidFill>
               </a:rPr>
-              <a:t>G03 · VBot Workplace · Lê Tuấn Anh · MSSV 2A202602952</a:t>
+              <a:t>G03 · Lê Tuấn Anh (2A202602952) · Hồ Thái Hòa (2A202602915) · Nguyễn Đình Lâm Phúc (2A202602986)</a:t>
             </a:r>
           </a:p>
         </p:txBody>
@@ -18718,7 +18786,7 @@
         <p:spPr>
           <a:xfrm>
             <a:off x="457200" y="6400800"/>
-            <a:ext cx="7315200" cy="365760"/>
+            <a:ext cx="9144000" cy="365760"/>
           </a:xfrm>
           <a:prstGeom prst="rect">
             <a:avLst/>
@@ -18742,7 +18810,7 @@
                   <a:srgbClr val="555F6B"/>
                 </a:solidFill>
               </a:rPr>
-              <a:t>G03 · VBot Workplace · Lê Tuấn Anh · MSSV 2A202602952</a:t>
+              <a:t>G03 · Lê Tuấn Anh (2A202602952) · Hồ Thái Hòa (2A202602915) · Nguyễn Đình Lâm Phúc (2A202602986)</a:t>
             </a:r>
           </a:p>
         </p:txBody>
@@ -20076,7 +20144,7 @@
         <p:spPr>
           <a:xfrm>
             <a:off x="457200" y="6400800"/>
-            <a:ext cx="7315200" cy="365760"/>
+            <a:ext cx="9144000" cy="365760"/>
           </a:xfrm>
           <a:prstGeom prst="rect">
             <a:avLst/>
@@ -20100,7 +20168,7 @@
                   <a:srgbClr val="555F6B"/>
                 </a:solidFill>
               </a:rPr>
-              <a:t>G03 · VBot Workplace · Lê Tuấn Anh · MSSV 2A202602952</a:t>
+              <a:t>G03 · Lê Tuấn Anh (2A202602952) · Hồ Thái Hòa (2A202602915) · Nguyễn Đình Lâm Phúc (2A202602986)</a:t>
             </a:r>
           </a:p>
         </p:txBody>
@@ -21043,7 +21111,7 @@
         <p:spPr>
           <a:xfrm>
             <a:off x="457200" y="6400800"/>
-            <a:ext cx="7315200" cy="365760"/>
+            <a:ext cx="9144000" cy="365760"/>
           </a:xfrm>
           <a:prstGeom prst="rect">
             <a:avLst/>
@@ -21067,7 +21135,7 @@
                   <a:srgbClr val="555F6B"/>
                 </a:solidFill>
               </a:rPr>
-              <a:t>G03 · VBot Workplace · Lê Tuấn Anh · MSSV 2A202602952</a:t>
+              <a:t>G03 · Lê Tuấn Anh (2A202602952) · Hồ Thái Hòa (2A202602915) · Nguyễn Đình Lâm Phúc (2A202602986)</a:t>
             </a:r>
           </a:p>
         </p:txBody>
@@ -21791,7 +21859,7 @@
         <p:spPr>
           <a:xfrm>
             <a:off x="457200" y="6400800"/>
-            <a:ext cx="7315200" cy="365760"/>
+            <a:ext cx="9144000" cy="365760"/>
           </a:xfrm>
           <a:prstGeom prst="rect">
             <a:avLst/>
@@ -21815,7 +21883,7 @@
                   <a:srgbClr val="555F6B"/>
                 </a:solidFill>
               </a:rPr>
-              <a:t>G03 · VBot Workplace · Lê Tuấn Anh · MSSV 2A202602952</a:t>
+              <a:t>G03 · Lê Tuấn Anh (2A202602952) · Hồ Thái Hòa (2A202602915) · Nguyễn Đình Lâm Phúc (2A202602986)</a:t>
             </a:r>
           </a:p>
         </p:txBody>

</xml_diff>

<commit_message>
Remove ops labor from the quote per coach guidance (anh-le)
TOTAL drops from 6,821.44 to 3,421.44 USD/month (1.71 USD/DAU).
Regenerate quote, slides, HTML, and talk script; update cloud
comparison and risk scenarios accordingly.

Co-Authored-By: Claude Opus 5.5 <noreply@anthropic.com>
</commit_message>
<xml_diff>
--- a/anh-le/G03_slide.pptx
+++ b/anh-le/G03_slide.pptx
@@ -3656,7 +3656,7 @@
                   <a:srgbClr val="BFD7EA"/>
                 </a:solidFill>
               </a:rPr>
-              <a:t>Tổng chi phí: 6.821,44 USD/tháng, tức 3,41 USD cho mỗi người dùng hoạt động (DAU)</a:t>
+              <a:t>Tổng chi phí: 3.421,44 USD/tháng, tức 1,71 USD cho mỗi người dùng hoạt động (DAU)</a:t>
             </a:r>
           </a:p>
           <a:p>
@@ -6535,7 +6535,7 @@
                   <a:srgbClr val="FFFFFF"/>
                 </a:solidFill>
               </a:rPr>
-              <a:t>11. Chi phí: một nửa là nhân sự, LLM chỉ 16%</a:t>
+              <a:t>11. Chi phí: LLM 32%, governance 24%</a:t>
             </a:r>
           </a:p>
         </p:txBody>
@@ -6573,7 +6573,7 @@
                   <a:srgbClr val="2E6FB7"/>
                 </a:solidFill>
               </a:rPr>
-              <a:t>Tổng 6.821,44 USD/tháng, tức 3,41 USD/DAU. Bảng dưới giải thích vì sao mỗi khoản ra con số này</a:t>
+              <a:t>Tổng 3.421,44 USD/tháng, tức 1,71 USD/DAU. Bảng dưới giải thích vì sao mỗi khoản ra con số này</a:t>
             </a:r>
           </a:p>
         </p:txBody>
@@ -6798,7 +6798,7 @@
                             <a:srgbClr val="555F6B"/>
                           </a:solidFill>
                         </a:rPr>
-                        <a:t>ops_labor (nhân sự)</a:t>
+                        <a:t>llm</a:t>
                       </a:r>
                     </a:p>
                   </a:txBody>
@@ -6819,7 +6819,7 @@
                             <a:srgbClr val="555F6B"/>
                           </a:solidFill>
                         </a:rPr>
-                        <a:t>3.400</a:t>
+                        <a:t>1.093</a:t>
                       </a:r>
                     </a:p>
                   </a:txBody>
@@ -6840,7 +6840,7 @@
                             <a:srgbClr val="555F6B"/>
                           </a:solidFill>
                         </a:rPr>
-                        <a:t>50%</a:t>
+                        <a:t>32%</a:t>
                       </a:r>
                     </a:p>
                   </a:txBody>
@@ -6861,7 +6861,7 @@
                             <a:srgbClr val="555F6B"/>
                           </a:solidFill>
                         </a:rPr>
-                        <a:t>2 kỹ sư trực luân phiên: SRE 5–8 năm (53,85 triệu VND) + AI/MLOps 3–4 năm (34,1 triệu VND) = 87,95 triệu VND ÷ 25.870 VND/USD</a:t>
+                        <a:t>Lượt × số lần gọi model × token × giá. Cấp 1: 386 · cấp 2: 288 · cấp 3: 161 · cấp 4: 105 · cấp 5: 7 + ảnh 147 (4.312 ảnh × 0,034)</a:t>
                       </a:r>
                     </a:p>
                   </a:txBody>
@@ -6882,7 +6882,7 @@
                             <a:srgbClr val="555F6B"/>
                           </a:solidFill>
                         </a:rPr>
-                        <a:t>Lớn nhất vì cố định: cần người trực để giữ 99,5% (H7), vận hành LiteLLM và eval. Không giảm khi ít người dùng</a:t>
+                        <a:t>Lớn nhất vì tăng theo lượt dùng. Vẫn nhỏ nhờ Haiku rẻ (0,10 USD/1M token vào) và 61% token vào đọc từ cache với giá 0,01</a:t>
                       </a:r>
                     </a:p>
                   </a:txBody>
@@ -6905,7 +6905,7 @@
                             <a:srgbClr val="555F6B"/>
                           </a:solidFill>
                         </a:rPr>
-                        <a:t>llm</a:t>
+                        <a:t>governance</a:t>
                       </a:r>
                     </a:p>
                   </a:txBody>
@@ -6926,7 +6926,7 @@
                             <a:srgbClr val="555F6B"/>
                           </a:solidFill>
                         </a:rPr>
-                        <a:t>1.093</a:t>
+                        <a:t>806</a:t>
                       </a:r>
                     </a:p>
                   </a:txBody>
@@ -6947,7 +6947,7 @@
                             <a:srgbClr val="555F6B"/>
                           </a:solidFill>
                         </a:rPr>
-                        <a:t>16%</a:t>
+                        <a:t>24%</a:t>
                       </a:r>
                     </a:p>
                   </a:txBody>
@@ -6968,7 +6968,7 @@
                             <a:srgbClr val="555F6B"/>
                           </a:solidFill>
                         </a:rPr>
-                        <a:t>Lượt × số lần gọi model × token × giá. Cấp 1: 386 · cấp 2: 288 · cấp 3: 161 · cấp 4: 105 · cấp 5: 7 + ảnh 147 (4.312 ảnh × 0,034)</a:t>
+                        <a:t>Guardrail: 2,81 tỉ token × 0,10 USD/1M = 281. Eval gate: 4 lần/tháng × 5 cấp × 100 nhiệm vụ = 525</a:t>
                       </a:r>
                     </a:p>
                   </a:txBody>
@@ -6989,7 +6989,7 @@
                             <a:srgbClr val="555F6B"/>
                           </a:solidFill>
                         </a:rPr>
-                        <a:t>Nhỏ vì Haiku rẻ (0,10 USD/1M token vào) và 61% token vào đọc từ cache với giá 0,01</a:t>
+                        <a:t>Eval đắt hơn guardrail vì Opus 5.5 vừa làm bài mẫu vừa chấm điểm</a:t>
                       </a:r>
                     </a:p>
                   </a:txBody>
@@ -7012,7 +7012,7 @@
                             <a:srgbClr val="555F6B"/>
                           </a:solidFill>
                         </a:rPr>
-                        <a:t>governance</a:t>
+                        <a:t>database</a:t>
                       </a:r>
                     </a:p>
                   </a:txBody>
@@ -7033,7 +7033,7 @@
                             <a:srgbClr val="555F6B"/>
                           </a:solidFill>
                         </a:rPr>
-                        <a:t>806</a:t>
+                        <a:t>467</a:t>
                       </a:r>
                     </a:p>
                   </a:txBody>
@@ -7054,7 +7054,7 @@
                             <a:srgbClr val="555F6B"/>
                           </a:solidFill>
                         </a:rPr>
-                        <a:t>12%</a:t>
+                        <a:t>14%</a:t>
                       </a:r>
                     </a:p>
                   </a:txBody>
@@ -7075,7 +7075,7 @@
                             <a:srgbClr val="555F6B"/>
                           </a:solidFill>
                         </a:rPr>
-                        <a:t>Guardrail: 2,81 tỉ token × 0,10 USD/1M = 281. Eval gate: 4 lần/tháng × 5 cấp × 100 nhiệm vụ = 525</a:t>
+                        <a:t>Postgres HA 2 vCPU, 13 GB × 730 giờ = 355 · SSD 150 GB = 71 · database staging = 41</a:t>
                       </a:r>
                     </a:p>
                   </a:txBody>
@@ -7096,7 +7096,7 @@
                             <a:srgbClr val="555F6B"/>
                           </a:solidFill>
                         </a:rPr>
-                        <a:t>Eval đắt hơn guardrail vì Opus 5.5 vừa làm bài mẫu vừa chấm điểm</a:t>
+                        <a:t>Chạy 24/7, có bản dự phòng ở zone khác. Chứa luôn vector và token, nên không cần dịch vụ riêng</a:t>
                       </a:r>
                     </a:p>
                   </a:txBody>
@@ -7119,7 +7119,7 @@
                             <a:srgbClr val="555F6B"/>
                           </a:solidFill>
                         </a:rPr>
-                        <a:t>database</a:t>
+                        <a:t>sandbox</a:t>
                       </a:r>
                     </a:p>
                   </a:txBody>
@@ -7140,7 +7140,7 @@
                             <a:srgbClr val="555F6B"/>
                           </a:solidFill>
                         </a:rPr>
-                        <a:t>467</a:t>
+                        <a:t>315</a:t>
                       </a:r>
                     </a:p>
                   </a:txBody>
@@ -7161,7 +7161,7 @@
                             <a:srgbClr val="555F6B"/>
                           </a:solidFill>
                         </a:rPr>
-                        <a:t>7%</a:t>
+                        <a:t>9%</a:t>
                       </a:r>
                     </a:p>
                   </a:txBody>
@@ -7182,7 +7182,7 @@
                             <a:srgbClr val="555F6B"/>
                           </a:solidFill>
                         </a:rPr>
-                        <a:t>Postgres HA 2 vCPU, 13 GB × 730 giờ = 355 · SSD 150 GB = 71 · database staging = 41</a:t>
+                        <a:t>140.800 lượt × 2 phút = 4.693 vCPU-giờ × 0,0549 + 9.386 GB-giờ × 0,0061</a:t>
                       </a:r>
                     </a:p>
                   </a:txBody>
@@ -7203,7 +7203,7 @@
                             <a:srgbClr val="555F6B"/>
                           </a:solidFill>
                         </a:rPr>
-                        <a:t>Chạy 24/7, có bản dự phòng ở zone khác. Chứa luôn vector và token, nên không cần dịch vụ riêng</a:t>
+                        <a:t>Là cận trên: thời gian chạy thật chưa đo, nên mỗi lượt tính đủ 2 phút tối đa</a:t>
                       </a:r>
                     </a:p>
                   </a:txBody>
@@ -7226,7 +7226,7 @@
                             <a:srgbClr val="555F6B"/>
                           </a:solidFill>
                         </a:rPr>
-                        <a:t>sandbox</a:t>
+                        <a:t>compute</a:t>
                       </a:r>
                     </a:p>
                   </a:txBody>
@@ -7247,7 +7247,7 @@
                             <a:srgbClr val="555F6B"/>
                           </a:solidFill>
                         </a:rPr>
-                        <a:t>315</a:t>
+                        <a:t>284</a:t>
                       </a:r>
                     </a:p>
                   </a:txBody>
@@ -7268,7 +7268,7 @@
                             <a:srgbClr val="555F6B"/>
                           </a:solidFill>
                         </a:rPr>
-                        <a:t>5%</a:t>
+                        <a:t>8%</a:t>
                       </a:r>
                     </a:p>
                   </a:txBody>
@@ -7289,7 +7289,7 @@
                             <a:srgbClr val="555F6B"/>
                           </a:solidFill>
                         </a:rPr>
-                        <a:t>140.800 lượt × 2 phút = 4.693 vCPU-giờ × 0,0549 + 9.386 GB-giờ × 0,0061</a:t>
+                        <a:t>Phí cụm GKE 0,10 USD/giờ × 730 = 73 · 3 loại pod (web, LiteLLM, worker): 2.970 vCPU-giờ + 7.920 GB-giờ = 211</a:t>
                       </a:r>
                     </a:p>
                   </a:txBody>
@@ -7310,7 +7310,7 @@
                             <a:srgbClr val="555F6B"/>
                           </a:solidFill>
                         </a:rPr>
-                        <a:t>Là cận trên: thời gian chạy thật chưa đo, nên mỗi lượt tính đủ 2 phút tối đa</a:t>
+                        <a:t>Nhỏ vì giờ hành chính chạy 2 pod mỗi loại, ngoài giờ chỉ 1 pod</a:t>
                       </a:r>
                     </a:p>
                   </a:txBody>
@@ -7333,7 +7333,7 @@
                             <a:srgbClr val="555F6B"/>
                           </a:solidFill>
                         </a:rPr>
-                        <a:t>10 khoản còn lại</a:t>
+                        <a:t>9 khoản còn lại</a:t>
                       </a:r>
                     </a:p>
                   </a:txBody>
@@ -7354,7 +7354,7 @@
                             <a:srgbClr val="555F6B"/>
                           </a:solidFill>
                         </a:rPr>
-                        <a:t>741</a:t>
+                        <a:t>457</a:t>
                       </a:r>
                     </a:p>
                   </a:txBody>
@@ -7375,7 +7375,7 @@
                             <a:srgbClr val="555F6B"/>
                           </a:solidFill>
                         </a:rPr>
-                        <a:t>11%</a:t>
+                        <a:t>13%</a:t>
                       </a:r>
                     </a:p>
                   </a:txBody>
@@ -7396,7 +7396,7 @@
                             <a:srgbClr val="555F6B"/>
                           </a:solidFill>
                         </a:rPr>
-                        <a:t>compute 284 · backup_dr 164 · object_storage 83 · network 64 · cache_queue 56 · …</a:t>
+                        <a:t>backup_dr 164 · object_storage 83 · network 64 · cache_queue 56 · load_balancer 29 · …</a:t>
                       </a:r>
                     </a:p>
                   </a:txBody>
@@ -7417,7 +7417,7 @@
                             <a:srgbClr val="555F6B"/>
                           </a:solidFill>
                         </a:rPr>
-                        <a:t>Hạ tầng gọn: 1 cụm GKE, 1 region, phần lớn chỉ chạy đủ trong giờ hành chính</a:t>
+                        <a:t>Hạ tầng gọn: 1 cụm GKE, 1 region</a:t>
                       </a:r>
                     </a:p>
                   </a:txBody>
@@ -7465,7 +7465,7 @@
                   <a:srgbClr val="555F6B"/>
                 </a:solidFill>
               </a:rPr>
-              <a:t>Đơn giá và bằng chứng từng dòng: Phụ lục A và G03_baogia.xlsx. Không dùng free tier, credit hay giá khuyến mãi.</a:t>
+              <a:t>Không gồm chi phí nhân sự vận hành (theo hướng dẫn của coach). Đơn giá và bằng chứng từng dòng: Phụ lục A và G03_baogia.xlsx.</a:t>
             </a:r>
           </a:p>
         </p:txBody>
@@ -8480,7 +8480,7 @@
                   <a:srgbClr val="2E6FB7"/>
                 </a:solidFill>
               </a:rPr>
-              <a:t>Khi đó chi phí lên 11.526 USD/tháng. Nhóm đã tính sẵn; LiteLLM đổi model bằng 1 dòng cấu hình</a:t>
+              <a:t>Khi đó chi phí lên 8.126 USD/tháng. Nhóm đã tính sẵn; LiteLLM đổi model bằng 1 dòng cấu hình</a:t>
             </a:r>
           </a:p>
         </p:txBody>
@@ -8682,7 +8682,7 @@
                             <a:srgbClr val="555F6B"/>
                           </a:solidFill>
                         </a:rPr>
-                        <a:t>6.821</a:t>
+                        <a:t>3.421</a:t>
                       </a:r>
                     </a:p>
                   </a:txBody>
@@ -8703,7 +8703,7 @@
                             <a:srgbClr val="555F6B"/>
                           </a:solidFill>
                         </a:rPr>
-                        <a:t>3,41</a:t>
+                        <a:t>1,71</a:t>
                       </a:r>
                     </a:p>
                   </a:txBody>
@@ -8747,7 +8747,7 @@
                             <a:srgbClr val="555F6B"/>
                           </a:solidFill>
                         </a:rPr>
-                        <a:t>8.826</a:t>
+                        <a:t>5.426</a:t>
                       </a:r>
                     </a:p>
                   </a:txBody>
@@ -8768,7 +8768,7 @@
                             <a:srgbClr val="555F6B"/>
                           </a:solidFill>
                         </a:rPr>
-                        <a:t>2,21</a:t>
+                        <a:t>1,36</a:t>
                       </a:r>
                     </a:p>
                   </a:txBody>
@@ -8812,7 +8812,7 @@
                             <a:srgbClr val="555F6B"/>
                           </a:solidFill>
                         </a:rPr>
-                        <a:t>7.263</a:t>
+                        <a:t>3.863</a:t>
                       </a:r>
                     </a:p>
                   </a:txBody>
@@ -8833,7 +8833,7 @@
                             <a:srgbClr val="555F6B"/>
                           </a:solidFill>
                         </a:rPr>
-                        <a:t>3,63</a:t>
+                        <a:t>1,93</a:t>
                       </a:r>
                     </a:p>
                   </a:txBody>
@@ -8877,7 +8877,7 @@
                             <a:srgbClr val="555F6B"/>
                           </a:solidFill>
                         </a:rPr>
-                        <a:t>6.085</a:t>
+                        <a:t>2.685</a:t>
                       </a:r>
                     </a:p>
                   </a:txBody>
@@ -8898,7 +8898,7 @@
                             <a:srgbClr val="555F6B"/>
                           </a:solidFill>
                         </a:rPr>
-                        <a:t>3,04</a:t>
+                        <a:t>1,34</a:t>
                       </a:r>
                     </a:p>
                   </a:txBody>
@@ -8942,7 +8942,7 @@
                             <a:srgbClr val="555F6B"/>
                           </a:solidFill>
                         </a:rPr>
-                        <a:t>11.526</a:t>
+                        <a:t>8.126</a:t>
                       </a:r>
                     </a:p>
                   </a:txBody>
@@ -8963,7 +8963,7 @@
                             <a:srgbClr val="555F6B"/>
                           </a:solidFill>
                         </a:rPr>
-                        <a:t>5,76</a:t>
+                        <a:t>4,06</a:t>
                       </a:r>
                     </a:p>
                   </a:txBody>
@@ -9106,7 +9106,7 @@
                   <a:srgbClr val="555F6B"/>
                 </a:solidFill>
               </a:rPr>
-              <a:t>Gần như cố định: 2 kỹ sư, cụm GKE, database, cache, cân bằng tải</a:t>
+              <a:t>Gần như cố định: cụm GKE, database, cache, cân bằng tải</a:t>
             </a:r>
           </a:p>
           <a:p>
@@ -9204,7 +9204,7 @@
                   <a:srgbClr val="555F6B"/>
                 </a:solidFill>
               </a:rPr>
-              <a:t>LiteLLM là open source, không có SLA → 2 kỹ sư trực, cố định phiên bản, test trên staging</a:t>
+              <a:t>LiteLLM là open source, không có SLA → đội vận hành trực, cố định phiên bản, test trên staging</a:t>
             </a:r>
           </a:p>
           <a:p>
@@ -10457,7 +10457,7 @@
                             <a:srgbClr val="555F6B"/>
                           </a:solidFill>
                         </a:rPr>
-                        <a:t>3.400,00</a:t>
+                        <a:t>0,00</a:t>
                       </a:r>
                     </a:p>
                   </a:txBody>
@@ -10501,7 +10501,7 @@
                             <a:srgbClr val="555F6B"/>
                           </a:solidFill>
                         </a:rPr>
-                        <a:t>6.821,44</a:t>
+                        <a:t>3.421,44</a:t>
                       </a:r>
                     </a:p>
                   </a:txBody>
@@ -16404,7 +16404,7 @@
                   <a:srgbClr val="2E6FB7"/>
                 </a:solidFill>
               </a:rPr>
-              <a:t>GCP Singapore vì rẻ nhất trong 3 cloud (6.821 USD/tháng; AWS 8.643, Azure 14.484). Số tròn là bước ở slide 3; chữ xanh là mã dòng trong báo giá</a:t>
+              <a:t>GCP Singapore vì rẻ nhất trong 3 cloud (3.421 USD/tháng; AWS 5.243, Azure 11.084). Số tròn là bước ở slide 3; chữ xanh là mã dòng trong báo giá</a:t>
             </a:r>
           </a:p>
         </p:txBody>
@@ -17765,71 +17765,7 @@
       </p:sp>
       <p:sp>
         <p:nvSpPr>
-          <p:cNvPr id="29" name="Rounded Rectangle 28"/>
-          <p:cNvSpPr/>
-          <p:nvPr/>
-        </p:nvSpPr>
-        <p:spPr>
-          <a:xfrm>
-            <a:off x="10149840" y="4480560"/>
-            <a:ext cx="1645920" cy="914400"/>
-          </a:xfrm>
-          <a:prstGeom prst="roundRect">
-            <a:avLst/>
-          </a:prstGeom>
-          <a:solidFill>
-            <a:srgbClr val="EEF3F8"/>
-          </a:solidFill>
-          <a:ln w="15875">
-            <a:solidFill>
-              <a:srgbClr val="2E6FB7"/>
-            </a:solidFill>
-          </a:ln>
-        </p:spPr>
-        <p:style>
-          <a:lnRef idx="1">
-            <a:schemeClr val="accent1"/>
-          </a:lnRef>
-          <a:fillRef idx="3">
-            <a:schemeClr val="accent1"/>
-          </a:fillRef>
-          <a:effectRef idx="2">
-            <a:schemeClr val="accent1"/>
-          </a:effectRef>
-          <a:fontRef idx="minor">
-            <a:schemeClr val="lt1"/>
-          </a:fontRef>
-        </p:style>
-        <p:txBody>
-          <a:bodyPr rtlCol="0" anchor="ctr" wrap="square" lIns="45720" rIns="45720"/>
-          <a:lstStyle/>
-          <a:p>
-            <a:pPr algn="ctr"/>
-            <a:r>
-              <a:rPr sz="1100" b="1">
-                <a:solidFill>
-                  <a:srgbClr val="1F3A5F"/>
-                </a:solidFill>
-              </a:rPr>
-              <a:t>2 kỹ sư vận hành</a:t>
-            </a:r>
-          </a:p>
-          <a:p>
-            <a:pPr algn="ctr"/>
-            <a:r>
-              <a:rPr sz="900" b="1">
-                <a:solidFill>
-                  <a:srgbClr val="1A8F7A"/>
-                </a:solidFill>
-              </a:rPr>
-              <a:t>ops_labor</a:t>
-            </a:r>
-          </a:p>
-        </p:txBody>
-      </p:sp>
-      <p:sp>
-        <p:nvSpPr>
-          <p:cNvPr id="30" name="Oval 29"/>
+          <p:cNvPr id="29" name="Oval 28"/>
           <p:cNvSpPr/>
           <p:nvPr/>
         </p:nvSpPr>
@@ -17880,7 +17816,7 @@
       </p:sp>
       <p:sp>
         <p:nvSpPr>
-          <p:cNvPr id="31" name="Oval 30"/>
+          <p:cNvPr id="30" name="Oval 29"/>
           <p:cNvSpPr/>
           <p:nvPr/>
         </p:nvSpPr>
@@ -17931,7 +17867,7 @@
       </p:sp>
       <p:sp>
         <p:nvSpPr>
-          <p:cNvPr id="32" name="Oval 31"/>
+          <p:cNvPr id="31" name="Oval 30"/>
           <p:cNvSpPr/>
           <p:nvPr/>
         </p:nvSpPr>
@@ -17982,7 +17918,7 @@
       </p:sp>
       <p:sp>
         <p:nvSpPr>
-          <p:cNvPr id="33" name="Oval 32"/>
+          <p:cNvPr id="32" name="Oval 31"/>
           <p:cNvSpPr/>
           <p:nvPr/>
         </p:nvSpPr>
@@ -18033,7 +17969,7 @@
       </p:sp>
       <p:sp>
         <p:nvSpPr>
-          <p:cNvPr id="34" name="Oval 33"/>
+          <p:cNvPr id="33" name="Oval 32"/>
           <p:cNvSpPr/>
           <p:nvPr/>
         </p:nvSpPr>
@@ -18084,7 +18020,7 @@
       </p:sp>
       <p:sp>
         <p:nvSpPr>
-          <p:cNvPr id="35" name="Oval 34"/>
+          <p:cNvPr id="34" name="Oval 33"/>
           <p:cNvSpPr/>
           <p:nvPr/>
         </p:nvSpPr>
@@ -18135,7 +18071,7 @@
       </p:sp>
       <p:sp>
         <p:nvSpPr>
-          <p:cNvPr id="36" name="TextBox 35"/>
+          <p:cNvPr id="35" name="TextBox 34"/>
           <p:cNvSpPr txBox="1"/>
           <p:nvPr/>
         </p:nvSpPr>
@@ -20316,7 +20252,7 @@
                             <a:srgbClr val="555F6B"/>
                           </a:solidFill>
                         </a:rPr>
-                        <a:t>GCP: 6.821 (tổng)</a:t>
+                        <a:t>GCP: 3.421 (tổng)</a:t>
                       </a:r>
                     </a:p>
                   </a:txBody>
@@ -20337,7 +20273,7 @@
                             <a:srgbClr val="555F6B"/>
                           </a:solidFill>
                         </a:rPr>
-                        <a:t>AWS 8.643 · Azure 14.484</a:t>
+                        <a:t>AWS 5.243 · Azure 11.084</a:t>
                       </a:r>
                     </a:p>
                   </a:txBody>
@@ -21261,7 +21197,7 @@
                             <a:srgbClr val="555F6B"/>
                           </a:solidFill>
                         </a:rPr>
-                        <a:t>GCP 6.821 = tổng 20 dòng của báo giá (Phụ lục A)</a:t>
+                        <a:t>GCP 3.421 = tổng các dòng của báo giá (Phụ lục A)</a:t>
                       </a:r>
                     </a:p>
                   </a:txBody>
@@ -21282,7 +21218,7 @@
                             <a:srgbClr val="555F6B"/>
                           </a:solidFill>
                         </a:rPr>
-                        <a:t>AWS 8.643, Azure 14.484: cùng khối lượng, tính theo giá của AWS, Azure. Nếu bỏ dòng governance, 3 cloud chênh nhau dưới 8%. Chênh lệch nằm ở guardrail + che PII: GCP 281, AWS ~1.910, Azure ~7.534</a:t>
+                        <a:t>AWS 5.243, Azure 11.084: cùng khối lượng, tính theo giá của AWS, Azure. Nếu bỏ dòng governance, 3 cloud chênh nhau dưới 16%. Chênh lệch nằm ở guardrail + che PII: GCP 281, AWS ~1.910, Azure ~7.534</a:t>
                       </a:r>
                     </a:p>
                   </a:txBody>

</xml_diff>

<commit_message>
Sort quote by cost (highest first) and add PDF export of slides (anh-le)
Co-Authored-By: Claude Opus 5.5 <noreply@anthropic.com>
</commit_message>
<xml_diff>
--- a/anh-le/G03_slide.pptx
+++ b/anh-le/G03_slide.pptx
@@ -9371,7 +9371,7 @@
                   <a:srgbClr val="2E6FB7"/>
                 </a:solidFill>
               </a:rPr>
-              <a:t>Chi tiết từng dòng (đơn giá × số lượng, kèm bằng chứng) nằm trong G03_baogia.xlsx</a:t>
+              <a:t>Sắp xếp từ cao tới thấp. Chi tiết từng dòng (đơn giá × số lượng, kèm bằng chứng) nằm trong G03_baogia.xlsx</a:t>
             </a:r>
           </a:p>
         </p:txBody>
@@ -9471,8 +9471,9 @@
                 <a:tableStyleId>{5C22544A-7EE6-4342-B048-85BDC9FD1C3A}</a:tableStyleId>
               </a:tblPr>
               <a:tblGrid>
-                <a:gridCol w="3200400"/>
-                <a:gridCol w="2286000"/>
+                <a:gridCol w="2743200"/>
+                <a:gridCol w="1645920"/>
+                <a:gridCol w="1097280"/>
               </a:tblGrid>
               <a:tr h="384048">
                 <a:tc>
@@ -9517,6 +9518,27 @@
                     </a:solidFill>
                   </a:tcPr>
                 </a:tc>
+                <a:tc>
+                  <a:txBody>
+                    <a:bodyPr/>
+                    <a:lstStyle/>
+                    <a:p>
+                      <a:r>
+                        <a:rPr sz="1200" b="1">
+                          <a:solidFill>
+                            <a:srgbClr val="FFFFFF"/>
+                          </a:solidFill>
+                        </a:rPr>
+                        <a:t>%</a:t>
+                      </a:r>
+                    </a:p>
+                  </a:txBody>
+                  <a:tcPr marL="45720" marR="45720" marT="18288" marB="18288">
+                    <a:solidFill>
+                      <a:srgbClr val="2E6FB7"/>
+                    </a:solidFill>
+                  </a:tcPr>
+                </a:tc>
               </a:tr>
               <a:tr h="384048">
                 <a:tc>
@@ -9530,7 +9552,7 @@
                             <a:srgbClr val="555F6B"/>
                           </a:solidFill>
                         </a:rPr>
-                        <a:t>compute</a:t>
+                        <a:t>llm</a:t>
                       </a:r>
                     </a:p>
                   </a:txBody>
@@ -9551,7 +9573,28 @@
                             <a:srgbClr val="555F6B"/>
                           </a:solidFill>
                         </a:rPr>
-                        <a:t>284,15</a:t>
+                        <a:t>1.093,34</a:t>
+                      </a:r>
+                    </a:p>
+                  </a:txBody>
+                  <a:tcPr marL="45720" marR="45720" marT="18288" marB="18288">
+                    <a:solidFill>
+                      <a:srgbClr val="EEF3F8"/>
+                    </a:solidFill>
+                  </a:tcPr>
+                </a:tc>
+                <a:tc>
+                  <a:txBody>
+                    <a:bodyPr/>
+                    <a:lstStyle/>
+                    <a:p>
+                      <a:r>
+                        <a:rPr sz="1200" b="0">
+                          <a:solidFill>
+                            <a:srgbClr val="555F6B"/>
+                          </a:solidFill>
+                        </a:rPr>
+                        <a:t>32,0%</a:t>
                       </a:r>
                     </a:p>
                   </a:txBody>
@@ -9574,7 +9617,7 @@
                             <a:srgbClr val="555F6B"/>
                           </a:solidFill>
                         </a:rPr>
-                        <a:t>llm</a:t>
+                        <a:t>governance</a:t>
                       </a:r>
                     </a:p>
                   </a:txBody>
@@ -9595,7 +9638,28 @@
                             <a:srgbClr val="555F6B"/>
                           </a:solidFill>
                         </a:rPr>
-                        <a:t>1.093,34</a:t>
+                        <a:t>805,98</a:t>
+                      </a:r>
+                    </a:p>
+                  </a:txBody>
+                  <a:tcPr marL="45720" marR="45720" marT="18288" marB="18288">
+                    <a:solidFill>
+                      <a:srgbClr val="FFFFFF"/>
+                    </a:solidFill>
+                  </a:tcPr>
+                </a:tc>
+                <a:tc>
+                  <a:txBody>
+                    <a:bodyPr/>
+                    <a:lstStyle/>
+                    <a:p>
+                      <a:r>
+                        <a:rPr sz="1200" b="0">
+                          <a:solidFill>
+                            <a:srgbClr val="555F6B"/>
+                          </a:solidFill>
+                        </a:rPr>
+                        <a:t>23,6%</a:t>
                       </a:r>
                     </a:p>
                   </a:txBody>
@@ -9618,7 +9682,7 @@
                             <a:srgbClr val="555F6B"/>
                           </a:solidFill>
                         </a:rPr>
-                        <a:t>embedding</a:t>
+                        <a:t>database</a:t>
                       </a:r>
                     </a:p>
                   </a:txBody>
@@ -9639,7 +9703,28 @@
                             <a:srgbClr val="555F6B"/>
                           </a:solidFill>
                         </a:rPr>
-                        <a:t>19,50</a:t>
+                        <a:t>466,71</a:t>
+                      </a:r>
+                    </a:p>
+                  </a:txBody>
+                  <a:tcPr marL="45720" marR="45720" marT="18288" marB="18288">
+                    <a:solidFill>
+                      <a:srgbClr val="EEF3F8"/>
+                    </a:solidFill>
+                  </a:tcPr>
+                </a:tc>
+                <a:tc>
+                  <a:txBody>
+                    <a:bodyPr/>
+                    <a:lstStyle/>
+                    <a:p>
+                      <a:r>
+                        <a:rPr sz="1200" b="0">
+                          <a:solidFill>
+                            <a:srgbClr val="555F6B"/>
+                          </a:solidFill>
+                        </a:rPr>
+                        <a:t>13,6%</a:t>
                       </a:r>
                     </a:p>
                   </a:txBody>
@@ -9662,7 +9747,7 @@
                             <a:srgbClr val="555F6B"/>
                           </a:solidFill>
                         </a:rPr>
-                        <a:t>gateway</a:t>
+                        <a:t>sandbox</a:t>
                       </a:r>
                     </a:p>
                   </a:txBody>
@@ -9683,7 +9768,28 @@
                             <a:srgbClr val="555F6B"/>
                           </a:solidFill>
                         </a:rPr>
-                        <a:t>0,00</a:t>
+                        <a:t>314,64</a:t>
+                      </a:r>
+                    </a:p>
+                  </a:txBody>
+                  <a:tcPr marL="45720" marR="45720" marT="18288" marB="18288">
+                    <a:solidFill>
+                      <a:srgbClr val="FFFFFF"/>
+                    </a:solidFill>
+                  </a:tcPr>
+                </a:tc>
+                <a:tc>
+                  <a:txBody>
+                    <a:bodyPr/>
+                    <a:lstStyle/>
+                    <a:p>
+                      <a:r>
+                        <a:rPr sz="1200" b="0">
+                          <a:solidFill>
+                            <a:srgbClr val="555F6B"/>
+                          </a:solidFill>
+                        </a:rPr>
+                        <a:t>9,2%</a:t>
                       </a:r>
                     </a:p>
                   </a:txBody>
@@ -9706,7 +9812,7 @@
                             <a:srgbClr val="555F6B"/>
                           </a:solidFill>
                         </a:rPr>
-                        <a:t>load_balancer</a:t>
+                        <a:t>compute</a:t>
                       </a:r>
                     </a:p>
                   </a:txBody>
@@ -9727,7 +9833,28 @@
                             <a:srgbClr val="555F6B"/>
                           </a:solidFill>
                         </a:rPr>
-                        <a:t>29,44</a:t>
+                        <a:t>284,15</a:t>
+                      </a:r>
+                    </a:p>
+                  </a:txBody>
+                  <a:tcPr marL="45720" marR="45720" marT="18288" marB="18288">
+                    <a:solidFill>
+                      <a:srgbClr val="EEF3F8"/>
+                    </a:solidFill>
+                  </a:tcPr>
+                </a:tc>
+                <a:tc>
+                  <a:txBody>
+                    <a:bodyPr/>
+                    <a:lstStyle/>
+                    <a:p>
+                      <a:r>
+                        <a:rPr sz="1200" b="0">
+                          <a:solidFill>
+                            <a:srgbClr val="555F6B"/>
+                          </a:solidFill>
+                        </a:rPr>
+                        <a:t>8,3%</a:t>
                       </a:r>
                     </a:p>
                   </a:txBody>
@@ -9750,7 +9877,7 @@
                             <a:srgbClr val="555F6B"/>
                           </a:solidFill>
                         </a:rPr>
-                        <a:t>authn</a:t>
+                        <a:t>backup_dr</a:t>
                       </a:r>
                     </a:p>
                   </a:txBody>
@@ -9771,7 +9898,28 @@
                             <a:srgbClr val="555F6B"/>
                           </a:solidFill>
                         </a:rPr>
-                        <a:t>0,00</a:t>
+                        <a:t>164,40</a:t>
+                      </a:r>
+                    </a:p>
+                  </a:txBody>
+                  <a:tcPr marL="45720" marR="45720" marT="18288" marB="18288">
+                    <a:solidFill>
+                      <a:srgbClr val="FFFFFF"/>
+                    </a:solidFill>
+                  </a:tcPr>
+                </a:tc>
+                <a:tc>
+                  <a:txBody>
+                    <a:bodyPr/>
+                    <a:lstStyle/>
+                    <a:p>
+                      <a:r>
+                        <a:rPr sz="1200" b="0">
+                          <a:solidFill>
+                            <a:srgbClr val="555F6B"/>
+                          </a:solidFill>
+                        </a:rPr>
+                        <a:t>4,8%</a:t>
                       </a:r>
                     </a:p>
                   </a:txBody>
@@ -9794,7 +9942,7 @@
                             <a:srgbClr val="555F6B"/>
                           </a:solidFill>
                         </a:rPr>
-                        <a:t>authz</a:t>
+                        <a:t>object_storage</a:t>
                       </a:r>
                     </a:p>
                   </a:txBody>
@@ -9815,7 +9963,28 @@
                             <a:srgbClr val="555F6B"/>
                           </a:solidFill>
                         </a:rPr>
-                        <a:t>0,00</a:t>
+                        <a:t>82,80</a:t>
+                      </a:r>
+                    </a:p>
+                  </a:txBody>
+                  <a:tcPr marL="45720" marR="45720" marT="18288" marB="18288">
+                    <a:solidFill>
+                      <a:srgbClr val="EEF3F8"/>
+                    </a:solidFill>
+                  </a:tcPr>
+                </a:tc>
+                <a:tc>
+                  <a:txBody>
+                    <a:bodyPr/>
+                    <a:lstStyle/>
+                    <a:p>
+                      <a:r>
+                        <a:rPr sz="1200" b="0">
+                          <a:solidFill>
+                            <a:srgbClr val="555F6B"/>
+                          </a:solidFill>
+                        </a:rPr>
+                        <a:t>2,4%</a:t>
                       </a:r>
                     </a:p>
                   </a:txBody>
@@ -9838,7 +10007,7 @@
                             <a:srgbClr val="555F6B"/>
                           </a:solidFill>
                         </a:rPr>
-                        <a:t>database</a:t>
+                        <a:t>network</a:t>
                       </a:r>
                     </a:p>
                   </a:txBody>
@@ -9859,7 +10028,28 @@
                             <a:srgbClr val="555F6B"/>
                           </a:solidFill>
                         </a:rPr>
-                        <a:t>466,71</a:t>
+                        <a:t>64,26</a:t>
+                      </a:r>
+                    </a:p>
+                  </a:txBody>
+                  <a:tcPr marL="45720" marR="45720" marT="18288" marB="18288">
+                    <a:solidFill>
+                      <a:srgbClr val="FFFFFF"/>
+                    </a:solidFill>
+                  </a:tcPr>
+                </a:tc>
+                <a:tc>
+                  <a:txBody>
+                    <a:bodyPr/>
+                    <a:lstStyle/>
+                    <a:p>
+                      <a:r>
+                        <a:rPr sz="1200" b="0">
+                          <a:solidFill>
+                            <a:srgbClr val="555F6B"/>
+                          </a:solidFill>
+                        </a:rPr>
+                        <a:t>1,9%</a:t>
                       </a:r>
                     </a:p>
                   </a:txBody>
@@ -9882,7 +10072,7 @@
                             <a:srgbClr val="555F6B"/>
                           </a:solidFill>
                         </a:rPr>
-                        <a:t>vector_db</a:t>
+                        <a:t>cache_queue</a:t>
                       </a:r>
                     </a:p>
                   </a:txBody>
@@ -9903,7 +10093,28 @@
                             <a:srgbClr val="555F6B"/>
                           </a:solidFill>
                         </a:rPr>
-                        <a:t>0,00</a:t>
+                        <a:t>55,75</a:t>
+                      </a:r>
+                    </a:p>
+                  </a:txBody>
+                  <a:tcPr marL="45720" marR="45720" marT="18288" marB="18288">
+                    <a:solidFill>
+                      <a:srgbClr val="EEF3F8"/>
+                    </a:solidFill>
+                  </a:tcPr>
+                </a:tc>
+                <a:tc>
+                  <a:txBody>
+                    <a:bodyPr/>
+                    <a:lstStyle/>
+                    <a:p>
+                      <a:r>
+                        <a:rPr sz="1200" b="0">
+                          <a:solidFill>
+                            <a:srgbClr val="555F6B"/>
+                          </a:solidFill>
+                        </a:rPr>
+                        <a:t>1,6%</a:t>
                       </a:r>
                     </a:p>
                   </a:txBody>
@@ -9926,7 +10137,7 @@
                             <a:srgbClr val="555F6B"/>
                           </a:solidFill>
                         </a:rPr>
-                        <a:t>object_storage</a:t>
+                        <a:t>load_balancer</a:t>
                       </a:r>
                     </a:p>
                   </a:txBody>
@@ -9947,7 +10158,28 @@
                             <a:srgbClr val="555F6B"/>
                           </a:solidFill>
                         </a:rPr>
-                        <a:t>82,80</a:t>
+                        <a:t>29,44</a:t>
+                      </a:r>
+                    </a:p>
+                  </a:txBody>
+                  <a:tcPr marL="45720" marR="45720" marT="18288" marB="18288">
+                    <a:solidFill>
+                      <a:srgbClr val="FFFFFF"/>
+                    </a:solidFill>
+                  </a:tcPr>
+                </a:tc>
+                <a:tc>
+                  <a:txBody>
+                    <a:bodyPr/>
+                    <a:lstStyle/>
+                    <a:p>
+                      <a:r>
+                        <a:rPr sz="1200" b="0">
+                          <a:solidFill>
+                            <a:srgbClr val="555F6B"/>
+                          </a:solidFill>
+                        </a:rPr>
+                        <a:t>0,9%</a:t>
                       </a:r>
                     </a:p>
                   </a:txBody>
@@ -9981,8 +10213,9 @@
                 <a:tableStyleId>{5C22544A-7EE6-4342-B048-85BDC9FD1C3A}</a:tableStyleId>
               </a:tblPr>
               <a:tblGrid>
-                <a:gridCol w="3200400"/>
-                <a:gridCol w="2286000"/>
+                <a:gridCol w="2743200"/>
+                <a:gridCol w="1645920"/>
+                <a:gridCol w="1097280"/>
               </a:tblGrid>
               <a:tr h="384048">
                 <a:tc>
@@ -10027,6 +10260,27 @@
                     </a:solidFill>
                   </a:tcPr>
                 </a:tc>
+                <a:tc>
+                  <a:txBody>
+                    <a:bodyPr/>
+                    <a:lstStyle/>
+                    <a:p>
+                      <a:r>
+                        <a:rPr sz="1200" b="1">
+                          <a:solidFill>
+                            <a:srgbClr val="FFFFFF"/>
+                          </a:solidFill>
+                        </a:rPr>
+                        <a:t>%</a:t>
+                      </a:r>
+                    </a:p>
+                  </a:txBody>
+                  <a:tcPr marL="45720" marR="45720" marT="18288" marB="18288">
+                    <a:solidFill>
+                      <a:srgbClr val="2E6FB7"/>
+                    </a:solidFill>
+                  </a:tcPr>
+                </a:tc>
               </a:tr>
               <a:tr h="384048">
                 <a:tc>
@@ -10040,7 +10294,7 @@
                             <a:srgbClr val="555F6B"/>
                           </a:solidFill>
                         </a:rPr>
-                        <a:t>cache_queue</a:t>
+                        <a:t>monitoring</a:t>
                       </a:r>
                     </a:p>
                   </a:txBody>
@@ -10061,7 +10315,28 @@
                             <a:srgbClr val="555F6B"/>
                           </a:solidFill>
                         </a:rPr>
-                        <a:t>55,75</a:t>
+                        <a:t>22,51</a:t>
+                      </a:r>
+                    </a:p>
+                  </a:txBody>
+                  <a:tcPr marL="45720" marR="45720" marT="18288" marB="18288">
+                    <a:solidFill>
+                      <a:srgbClr val="EEF3F8"/>
+                    </a:solidFill>
+                  </a:tcPr>
+                </a:tc>
+                <a:tc>
+                  <a:txBody>
+                    <a:bodyPr/>
+                    <a:lstStyle/>
+                    <a:p>
+                      <a:r>
+                        <a:rPr sz="1200" b="0">
+                          <a:solidFill>
+                            <a:srgbClr val="555F6B"/>
+                          </a:solidFill>
+                        </a:rPr>
+                        <a:t>0,7%</a:t>
                       </a:r>
                     </a:p>
                   </a:txBody>
@@ -10084,7 +10359,7 @@
                             <a:srgbClr val="555F6B"/>
                           </a:solidFill>
                         </a:rPr>
-                        <a:t>sandbox</a:t>
+                        <a:t>embedding</a:t>
                       </a:r>
                     </a:p>
                   </a:txBody>
@@ -10105,7 +10380,28 @@
                             <a:srgbClr val="555F6B"/>
                           </a:solidFill>
                         </a:rPr>
-                        <a:t>314,64</a:t>
+                        <a:t>19,50</a:t>
+                      </a:r>
+                    </a:p>
+                  </a:txBody>
+                  <a:tcPr marL="45720" marR="45720" marT="18288" marB="18288">
+                    <a:solidFill>
+                      <a:srgbClr val="FFFFFF"/>
+                    </a:solidFill>
+                  </a:tcPr>
+                </a:tc>
+                <a:tc>
+                  <a:txBody>
+                    <a:bodyPr/>
+                    <a:lstStyle/>
+                    <a:p>
+                      <a:r>
+                        <a:rPr sz="1200" b="0">
+                          <a:solidFill>
+                            <a:srgbClr val="555F6B"/>
+                          </a:solidFill>
+                        </a:rPr>
+                        <a:t>0,6%</a:t>
                       </a:r>
                     </a:p>
                   </a:txBody>
@@ -10128,7 +10424,7 @@
                             <a:srgbClr val="555F6B"/>
                           </a:solidFill>
                         </a:rPr>
-                        <a:t>connectors</a:t>
+                        <a:t>cicd</a:t>
                       </a:r>
                     </a:p>
                   </a:txBody>
@@ -10149,7 +10445,28 @@
                             <a:srgbClr val="555F6B"/>
                           </a:solidFill>
                         </a:rPr>
-                        <a:t>0,00</a:t>
+                        <a:t>14,00</a:t>
+                      </a:r>
+                    </a:p>
+                  </a:txBody>
+                  <a:tcPr marL="45720" marR="45720" marT="18288" marB="18288">
+                    <a:solidFill>
+                      <a:srgbClr val="EEF3F8"/>
+                    </a:solidFill>
+                  </a:tcPr>
+                </a:tc>
+                <a:tc>
+                  <a:txBody>
+                    <a:bodyPr/>
+                    <a:lstStyle/>
+                    <a:p>
+                      <a:r>
+                        <a:rPr sz="1200" b="0">
+                          <a:solidFill>
+                            <a:srgbClr val="555F6B"/>
+                          </a:solidFill>
+                        </a:rPr>
+                        <a:t>0,4%</a:t>
                       </a:r>
                     </a:p>
                   </a:txBody>
@@ -10203,6 +10520,27 @@
                     </a:solidFill>
                   </a:tcPr>
                 </a:tc>
+                <a:tc>
+                  <a:txBody>
+                    <a:bodyPr/>
+                    <a:lstStyle/>
+                    <a:p>
+                      <a:r>
+                        <a:rPr sz="1200" b="0">
+                          <a:solidFill>
+                            <a:srgbClr val="555F6B"/>
+                          </a:solidFill>
+                        </a:rPr>
+                        <a:t>0,1%</a:t>
+                      </a:r>
+                    </a:p>
+                  </a:txBody>
+                  <a:tcPr marL="45720" marR="45720" marT="18288" marB="18288">
+                    <a:solidFill>
+                      <a:srgbClr val="FFFFFF"/>
+                    </a:solidFill>
+                  </a:tcPr>
+                </a:tc>
               </a:tr>
               <a:tr h="384048">
                 <a:tc>
@@ -10216,7 +10554,7 @@
                             <a:srgbClr val="555F6B"/>
                           </a:solidFill>
                         </a:rPr>
-                        <a:t>backup_dr</a:t>
+                        <a:t>authn</a:t>
                       </a:r>
                     </a:p>
                   </a:txBody>
@@ -10237,7 +10575,28 @@
                             <a:srgbClr val="555F6B"/>
                           </a:solidFill>
                         </a:rPr>
-                        <a:t>164,40</a:t>
+                        <a:t>0,00</a:t>
+                      </a:r>
+                    </a:p>
+                  </a:txBody>
+                  <a:tcPr marL="45720" marR="45720" marT="18288" marB="18288">
+                    <a:solidFill>
+                      <a:srgbClr val="EEF3F8"/>
+                    </a:solidFill>
+                  </a:tcPr>
+                </a:tc>
+                <a:tc>
+                  <a:txBody>
+                    <a:bodyPr/>
+                    <a:lstStyle/>
+                    <a:p>
+                      <a:r>
+                        <a:rPr sz="1200" b="0">
+                          <a:solidFill>
+                            <a:srgbClr val="555F6B"/>
+                          </a:solidFill>
+                        </a:rPr>
+                        <a:t>0,0%</a:t>
                       </a:r>
                     </a:p>
                   </a:txBody>
@@ -10260,7 +10619,7 @@
                             <a:srgbClr val="555F6B"/>
                           </a:solidFill>
                         </a:rPr>
-                        <a:t>monitoring</a:t>
+                        <a:t>authz</a:t>
                       </a:r>
                     </a:p>
                   </a:txBody>
@@ -10281,7 +10640,28 @@
                             <a:srgbClr val="555F6B"/>
                           </a:solidFill>
                         </a:rPr>
-                        <a:t>22,51</a:t>
+                        <a:t>0,00</a:t>
+                      </a:r>
+                    </a:p>
+                  </a:txBody>
+                  <a:tcPr marL="45720" marR="45720" marT="18288" marB="18288">
+                    <a:solidFill>
+                      <a:srgbClr val="FFFFFF"/>
+                    </a:solidFill>
+                  </a:tcPr>
+                </a:tc>
+                <a:tc>
+                  <a:txBody>
+                    <a:bodyPr/>
+                    <a:lstStyle/>
+                    <a:p>
+                      <a:r>
+                        <a:rPr sz="1200" b="0">
+                          <a:solidFill>
+                            <a:srgbClr val="555F6B"/>
+                          </a:solidFill>
+                        </a:rPr>
+                        <a:t>0,0%</a:t>
                       </a:r>
                     </a:p>
                   </a:txBody>
@@ -10304,7 +10684,7 @@
                             <a:srgbClr val="555F6B"/>
                           </a:solidFill>
                         </a:rPr>
-                        <a:t>governance</a:t>
+                        <a:t>connectors</a:t>
                       </a:r>
                     </a:p>
                   </a:txBody>
@@ -10325,7 +10705,28 @@
                             <a:srgbClr val="555F6B"/>
                           </a:solidFill>
                         </a:rPr>
-                        <a:t>805,98</a:t>
+                        <a:t>0,00</a:t>
+                      </a:r>
+                    </a:p>
+                  </a:txBody>
+                  <a:tcPr marL="45720" marR="45720" marT="18288" marB="18288">
+                    <a:solidFill>
+                      <a:srgbClr val="EEF3F8"/>
+                    </a:solidFill>
+                  </a:tcPr>
+                </a:tc>
+                <a:tc>
+                  <a:txBody>
+                    <a:bodyPr/>
+                    <a:lstStyle/>
+                    <a:p>
+                      <a:r>
+                        <a:rPr sz="1200" b="0">
+                          <a:solidFill>
+                            <a:srgbClr val="555F6B"/>
+                          </a:solidFill>
+                        </a:rPr>
+                        <a:t>0,0%</a:t>
                       </a:r>
                     </a:p>
                   </a:txBody>
@@ -10348,7 +10749,7 @@
                             <a:srgbClr val="555F6B"/>
                           </a:solidFill>
                         </a:rPr>
-                        <a:t>network</a:t>
+                        <a:t>gateway</a:t>
                       </a:r>
                     </a:p>
                   </a:txBody>
@@ -10369,7 +10770,28 @@
                             <a:srgbClr val="555F6B"/>
                           </a:solidFill>
                         </a:rPr>
-                        <a:t>64,26</a:t>
+                        <a:t>0,00</a:t>
+                      </a:r>
+                    </a:p>
+                  </a:txBody>
+                  <a:tcPr marL="45720" marR="45720" marT="18288" marB="18288">
+                    <a:solidFill>
+                      <a:srgbClr val="FFFFFF"/>
+                    </a:solidFill>
+                  </a:tcPr>
+                </a:tc>
+                <a:tc>
+                  <a:txBody>
+                    <a:bodyPr/>
+                    <a:lstStyle/>
+                    <a:p>
+                      <a:r>
+                        <a:rPr sz="1200" b="0">
+                          <a:solidFill>
+                            <a:srgbClr val="555F6B"/>
+                          </a:solidFill>
+                        </a:rPr>
+                        <a:t>0,0%</a:t>
                       </a:r>
                     </a:p>
                   </a:txBody>
@@ -10392,7 +10814,7 @@
                             <a:srgbClr val="555F6B"/>
                           </a:solidFill>
                         </a:rPr>
-                        <a:t>cicd</a:t>
+                        <a:t>ops_labor</a:t>
                       </a:r>
                     </a:p>
                   </a:txBody>
@@ -10413,7 +10835,28 @@
                             <a:srgbClr val="555F6B"/>
                           </a:solidFill>
                         </a:rPr>
-                        <a:t>14,00</a:t>
+                        <a:t>0,00</a:t>
+                      </a:r>
+                    </a:p>
+                  </a:txBody>
+                  <a:tcPr marL="45720" marR="45720" marT="18288" marB="18288">
+                    <a:solidFill>
+                      <a:srgbClr val="EEF3F8"/>
+                    </a:solidFill>
+                  </a:tcPr>
+                </a:tc>
+                <a:tc>
+                  <a:txBody>
+                    <a:bodyPr/>
+                    <a:lstStyle/>
+                    <a:p>
+                      <a:r>
+                        <a:rPr sz="1200" b="0">
+                          <a:solidFill>
+                            <a:srgbClr val="555F6B"/>
+                          </a:solidFill>
+                        </a:rPr>
+                        <a:t>0,0%</a:t>
                       </a:r>
                     </a:p>
                   </a:txBody>
@@ -10436,7 +10879,7 @@
                             <a:srgbClr val="555F6B"/>
                           </a:solidFill>
                         </a:rPr>
-                        <a:t>ops_labor</a:t>
+                        <a:t>vector_db</a:t>
                       </a:r>
                     </a:p>
                   </a:txBody>
@@ -10458,6 +10901,27 @@
                           </a:solidFill>
                         </a:rPr>
                         <a:t>0,00</a:t>
+                      </a:r>
+                    </a:p>
+                  </a:txBody>
+                  <a:tcPr marL="45720" marR="45720" marT="18288" marB="18288">
+                    <a:solidFill>
+                      <a:srgbClr val="FFFFFF"/>
+                    </a:solidFill>
+                  </a:tcPr>
+                </a:tc>
+                <a:tc>
+                  <a:txBody>
+                    <a:bodyPr/>
+                    <a:lstStyle/>
+                    <a:p>
+                      <a:r>
+                        <a:rPr sz="1200" b="0">
+                          <a:solidFill>
+                            <a:srgbClr val="555F6B"/>
+                          </a:solidFill>
+                        </a:rPr>
+                        <a:t>0,0%</a:t>
                       </a:r>
                     </a:p>
                   </a:txBody>
@@ -10502,6 +10966,27 @@
                           </a:solidFill>
                         </a:rPr>
                         <a:t>3.421,44</a:t>
+                      </a:r>
+                    </a:p>
+                  </a:txBody>
+                  <a:tcPr marL="45720" marR="45720" marT="18288" marB="18288">
+                    <a:solidFill>
+                      <a:srgbClr val="EEF3F8"/>
+                    </a:solidFill>
+                  </a:tcPr>
+                </a:tc>
+                <a:tc>
+                  <a:txBody>
+                    <a:bodyPr/>
+                    <a:lstStyle/>
+                    <a:p>
+                      <a:r>
+                        <a:rPr sz="1200" b="0">
+                          <a:solidFill>
+                            <a:srgbClr val="555F6B"/>
+                          </a:solidFill>
+                        </a:rPr>
+                        <a:t>100%</a:t>
                       </a:r>
                     </a:p>
                   </a:txBody>

</xml_diff>